<commit_message>
new wee 11 stuff
</commit_message>
<xml_diff>
--- a/topic-11-week11/unit-2/talk-1/platforms1.pptx
+++ b/topic-11-week11/unit-2/talk-1/platforms1.pptx
@@ -2278,13 +2278,13 @@
       <dgm:prSet presAssocID="{4817AE45-9867-4B80-8CC0-686BACACC02F}" presName="iconRect" presStyleLbl="node1" presStyleIdx="0" presStyleCnt="3"/>
       <dgm:spPr>
         <a:blipFill>
-          <a:blip xmlns:r="http://schemas.openxmlformats.org/officeDocument/2006/relationships" r:embed="rId1">
+          <a:blip xmlns:r="http://schemas.openxmlformats.org/officeDocument/2006/relationships">
             <a:extLst>
               <a:ext uri="{28A0092B-C50C-407E-A947-70E740481C1C}">
                 <a14:useLocalDpi xmlns:a14="http://schemas.microsoft.com/office/drawing/2010/main" val="0"/>
               </a:ext>
               <a:ext uri="{96DAC541-7B7A-43D3-8B79-37D633B846F1}">
-                <asvg:svgBlip xmlns:asvg="http://schemas.microsoft.com/office/drawing/2016/SVG/main" r:embed="rId2"/>
+                <asvg:svgBlip xmlns:asvg="http://schemas.microsoft.com/office/drawing/2016/SVG/main" r:embed="rId1"/>
               </a:ext>
             </a:extLst>
           </a:blip>
@@ -2331,13 +2331,13 @@
       <dgm:prSet presAssocID="{47C54959-3B86-4FA9-94D1-D346A8BAC971}" presName="iconRect" presStyleLbl="node1" presStyleIdx="1" presStyleCnt="3"/>
       <dgm:spPr>
         <a:blipFill>
-          <a:blip xmlns:r="http://schemas.openxmlformats.org/officeDocument/2006/relationships" r:embed="rId3">
+          <a:blip xmlns:r="http://schemas.openxmlformats.org/officeDocument/2006/relationships">
             <a:extLst>
               <a:ext uri="{28A0092B-C50C-407E-A947-70E740481C1C}">
                 <a14:useLocalDpi xmlns:a14="http://schemas.microsoft.com/office/drawing/2010/main" val="0"/>
               </a:ext>
               <a:ext uri="{96DAC541-7B7A-43D3-8B79-37D633B846F1}">
-                <asvg:svgBlip xmlns:asvg="http://schemas.microsoft.com/office/drawing/2016/SVG/main" r:embed="rId4"/>
+                <asvg:svgBlip xmlns:asvg="http://schemas.microsoft.com/office/drawing/2016/SVG/main" r:embed="rId2"/>
               </a:ext>
             </a:extLst>
           </a:blip>
@@ -2384,13 +2384,13 @@
       <dgm:prSet presAssocID="{A36A58F8-A2E1-4C2E-A052-7D72CF0CD4E7}" presName="iconRect" presStyleLbl="node1" presStyleIdx="2" presStyleCnt="3"/>
       <dgm:spPr>
         <a:blipFill>
-          <a:blip xmlns:r="http://schemas.openxmlformats.org/officeDocument/2006/relationships" r:embed="rId5">
+          <a:blip xmlns:r="http://schemas.openxmlformats.org/officeDocument/2006/relationships">
             <a:extLst>
               <a:ext uri="{28A0092B-C50C-407E-A947-70E740481C1C}">
                 <a14:useLocalDpi xmlns:a14="http://schemas.microsoft.com/office/drawing/2010/main" val="0"/>
               </a:ext>
               <a:ext uri="{96DAC541-7B7A-43D3-8B79-37D633B846F1}">
-                <asvg:svgBlip xmlns:asvg="http://schemas.microsoft.com/office/drawing/2016/SVG/main" r:embed="rId6"/>
+                <asvg:svgBlip xmlns:asvg="http://schemas.microsoft.com/office/drawing/2016/SVG/main" r:embed="rId3"/>
               </a:ext>
             </a:extLst>
           </a:blip>
@@ -3151,13 +3151,13 @@
           <a:avLst/>
         </a:prstGeom>
         <a:blipFill>
-          <a:blip xmlns:r="http://schemas.openxmlformats.org/officeDocument/2006/relationships" r:embed="rId1">
+          <a:blip xmlns:r="http://schemas.openxmlformats.org/officeDocument/2006/relationships">
             <a:extLst>
               <a:ext uri="{28A0092B-C50C-407E-A947-70E740481C1C}">
                 <a14:useLocalDpi xmlns:a14="http://schemas.microsoft.com/office/drawing/2010/main" val="0"/>
               </a:ext>
               <a:ext uri="{96DAC541-7B7A-43D3-8B79-37D633B846F1}">
-                <asvg:svgBlip xmlns:asvg="http://schemas.microsoft.com/office/drawing/2016/SVG/main" r:embed="rId2"/>
+                <asvg:svgBlip xmlns:asvg="http://schemas.microsoft.com/office/drawing/2016/SVG/main" r:embed="rId1"/>
               </a:ext>
             </a:extLst>
           </a:blip>
@@ -3300,13 +3300,13 @@
           <a:avLst/>
         </a:prstGeom>
         <a:blipFill>
-          <a:blip xmlns:r="http://schemas.openxmlformats.org/officeDocument/2006/relationships" r:embed="rId3">
+          <a:blip xmlns:r="http://schemas.openxmlformats.org/officeDocument/2006/relationships">
             <a:extLst>
               <a:ext uri="{28A0092B-C50C-407E-A947-70E740481C1C}">
                 <a14:useLocalDpi xmlns:a14="http://schemas.microsoft.com/office/drawing/2010/main" val="0"/>
               </a:ext>
               <a:ext uri="{96DAC541-7B7A-43D3-8B79-37D633B846F1}">
-                <asvg:svgBlip xmlns:asvg="http://schemas.microsoft.com/office/drawing/2016/SVG/main" r:embed="rId4"/>
+                <asvg:svgBlip xmlns:asvg="http://schemas.microsoft.com/office/drawing/2016/SVG/main" r:embed="rId2"/>
               </a:ext>
             </a:extLst>
           </a:blip>
@@ -3449,13 +3449,13 @@
           <a:avLst/>
         </a:prstGeom>
         <a:blipFill>
-          <a:blip xmlns:r="http://schemas.openxmlformats.org/officeDocument/2006/relationships" r:embed="rId5">
+          <a:blip xmlns:r="http://schemas.openxmlformats.org/officeDocument/2006/relationships">
             <a:extLst>
               <a:ext uri="{28A0092B-C50C-407E-A947-70E740481C1C}">
                 <a14:useLocalDpi xmlns:a14="http://schemas.microsoft.com/office/drawing/2010/main" val="0"/>
               </a:ext>
               <a:ext uri="{96DAC541-7B7A-43D3-8B79-37D633B846F1}">
-                <asvg:svgBlip xmlns:asvg="http://schemas.microsoft.com/office/drawing/2016/SVG/main" r:embed="rId6"/>
+                <asvg:svgBlip xmlns:asvg="http://schemas.microsoft.com/office/drawing/2016/SVG/main" r:embed="rId3"/>
               </a:ext>
             </a:extLst>
           </a:blip>
@@ -6088,7 +6088,7 @@
           <a:p>
             <a:fld id="{2E3CA026-0B95-4A00-933D-6AE5D99250E8}" type="datetimeFigureOut">
               <a:rPr lang="en-IE" smtClean="0"/>
-              <a:t>03/12/2025</a:t>
+              <a:t>29/04/2026</a:t>
             </a:fld>
             <a:endParaRPr lang="en-IE"/>
           </a:p>
@@ -6487,7 +6487,7 @@
           <a:p>
             <a:fld id="{846CE7D5-CF57-46EF-B807-FDD0502418D4}" type="datetimeFigureOut">
               <a:rPr lang="en-US" smtClean="0"/>
-              <a:t>12/3/2025</a:t>
+              <a:t>4/29/2026</a:t>
             </a:fld>
             <a:endParaRPr lang="en-US"/>
           </a:p>
@@ -6657,7 +6657,7 @@
           <a:p>
             <a:fld id="{846CE7D5-CF57-46EF-B807-FDD0502418D4}" type="datetimeFigureOut">
               <a:rPr lang="en-US" smtClean="0"/>
-              <a:t>12/3/2025</a:t>
+              <a:t>4/29/2026</a:t>
             </a:fld>
             <a:endParaRPr lang="en-US"/>
           </a:p>
@@ -6837,7 +6837,7 @@
           <a:p>
             <a:fld id="{846CE7D5-CF57-46EF-B807-FDD0502418D4}" type="datetimeFigureOut">
               <a:rPr lang="en-US" smtClean="0"/>
-              <a:t>12/3/2025</a:t>
+              <a:t>4/29/2026</a:t>
             </a:fld>
             <a:endParaRPr lang="en-US"/>
           </a:p>
@@ -7007,7 +7007,7 @@
           <a:p>
             <a:fld id="{846CE7D5-CF57-46EF-B807-FDD0502418D4}" type="datetimeFigureOut">
               <a:rPr lang="en-US" smtClean="0"/>
-              <a:t>12/3/2025</a:t>
+              <a:t>4/29/2026</a:t>
             </a:fld>
             <a:endParaRPr lang="en-US"/>
           </a:p>
@@ -7253,7 +7253,7 @@
           <a:p>
             <a:fld id="{846CE7D5-CF57-46EF-B807-FDD0502418D4}" type="datetimeFigureOut">
               <a:rPr lang="en-US" smtClean="0"/>
-              <a:t>12/3/2025</a:t>
+              <a:t>4/29/2026</a:t>
             </a:fld>
             <a:endParaRPr lang="en-US"/>
           </a:p>
@@ -7485,7 +7485,7 @@
           <a:p>
             <a:fld id="{846CE7D5-CF57-46EF-B807-FDD0502418D4}" type="datetimeFigureOut">
               <a:rPr lang="en-US" smtClean="0"/>
-              <a:t>12/3/2025</a:t>
+              <a:t>4/29/2026</a:t>
             </a:fld>
             <a:endParaRPr lang="en-US"/>
           </a:p>
@@ -7852,7 +7852,7 @@
           <a:p>
             <a:fld id="{846CE7D5-CF57-46EF-B807-FDD0502418D4}" type="datetimeFigureOut">
               <a:rPr lang="en-US" smtClean="0"/>
-              <a:t>12/3/2025</a:t>
+              <a:t>4/29/2026</a:t>
             </a:fld>
             <a:endParaRPr lang="en-US"/>
           </a:p>
@@ -7970,7 +7970,7 @@
           <a:p>
             <a:fld id="{846CE7D5-CF57-46EF-B807-FDD0502418D4}" type="datetimeFigureOut">
               <a:rPr lang="en-US" smtClean="0"/>
-              <a:t>12/3/2025</a:t>
+              <a:t>4/29/2026</a:t>
             </a:fld>
             <a:endParaRPr lang="en-US"/>
           </a:p>
@@ -8065,7 +8065,7 @@
           <a:p>
             <a:fld id="{846CE7D5-CF57-46EF-B807-FDD0502418D4}" type="datetimeFigureOut">
               <a:rPr lang="en-US" smtClean="0"/>
-              <a:t>12/3/2025</a:t>
+              <a:t>4/29/2026</a:t>
             </a:fld>
             <a:endParaRPr lang="en-US"/>
           </a:p>
@@ -8342,7 +8342,7 @@
           <a:p>
             <a:fld id="{846CE7D5-CF57-46EF-B807-FDD0502418D4}" type="datetimeFigureOut">
               <a:rPr lang="en-US" smtClean="0"/>
-              <a:t>12/3/2025</a:t>
+              <a:t>4/29/2026</a:t>
             </a:fld>
             <a:endParaRPr lang="en-US"/>
           </a:p>
@@ -8599,7 +8599,7 @@
           <a:p>
             <a:fld id="{846CE7D5-CF57-46EF-B807-FDD0502418D4}" type="datetimeFigureOut">
               <a:rPr lang="en-US" smtClean="0"/>
-              <a:t>12/3/2025</a:t>
+              <a:t>4/29/2026</a:t>
             </a:fld>
             <a:endParaRPr lang="en-US"/>
           </a:p>
@@ -8812,7 +8812,7 @@
           <a:p>
             <a:fld id="{846CE7D5-CF57-46EF-B807-FDD0502418D4}" type="datetimeFigureOut">
               <a:rPr lang="en-US" smtClean="0"/>
-              <a:t>12/3/2025</a:t>
+              <a:t>4/29/2026</a:t>
             </a:fld>
             <a:endParaRPr lang="en-US"/>
           </a:p>
@@ -10484,73 +10484,73 @@
           <a:custGeom>
             <a:avLst/>
             <a:gdLst>
-              <a:gd name="connsiteX0" fmla="*/ 0 w 3474720"/>
-              <a:gd name="connsiteY0" fmla="*/ 0 h 18288"/>
-              <a:gd name="connsiteX1" fmla="*/ 694944 w 3474720"/>
-              <a:gd name="connsiteY1" fmla="*/ 0 h 18288"/>
-              <a:gd name="connsiteX2" fmla="*/ 1355141 w 3474720"/>
-              <a:gd name="connsiteY2" fmla="*/ 0 h 18288"/>
-              <a:gd name="connsiteX3" fmla="*/ 2015338 w 3474720"/>
-              <a:gd name="connsiteY3" fmla="*/ 0 h 18288"/>
-              <a:gd name="connsiteX4" fmla="*/ 2779776 w 3474720"/>
-              <a:gd name="connsiteY4" fmla="*/ 0 h 18288"/>
-              <a:gd name="connsiteX5" fmla="*/ 3474720 w 3474720"/>
-              <a:gd name="connsiteY5" fmla="*/ 0 h 18288"/>
-              <a:gd name="connsiteX6" fmla="*/ 3474720 w 3474720"/>
-              <a:gd name="connsiteY6" fmla="*/ 18288 h 18288"/>
-              <a:gd name="connsiteX7" fmla="*/ 2779776 w 3474720"/>
-              <a:gd name="connsiteY7" fmla="*/ 18288 h 18288"/>
-              <a:gd name="connsiteX8" fmla="*/ 2189074 w 3474720"/>
-              <a:gd name="connsiteY8" fmla="*/ 18288 h 18288"/>
-              <a:gd name="connsiteX9" fmla="*/ 1528877 w 3474720"/>
-              <a:gd name="connsiteY9" fmla="*/ 18288 h 18288"/>
-              <a:gd name="connsiteX10" fmla="*/ 868680 w 3474720"/>
-              <a:gd name="connsiteY10" fmla="*/ 18288 h 18288"/>
-              <a:gd name="connsiteX11" fmla="*/ 0 w 3474720"/>
-              <a:gd name="connsiteY11" fmla="*/ 18288 h 18288"/>
-              <a:gd name="connsiteX12" fmla="*/ 0 w 3474720"/>
-              <a:gd name="connsiteY12" fmla="*/ 0 h 18288"/>
+              <a:gd name="csX0" fmla="*/ 0 w 3474720"/>
+              <a:gd name="csY0" fmla="*/ 0 h 18288"/>
+              <a:gd name="csX1" fmla="*/ 694944 w 3474720"/>
+              <a:gd name="csY1" fmla="*/ 0 h 18288"/>
+              <a:gd name="csX2" fmla="*/ 1355141 w 3474720"/>
+              <a:gd name="csY2" fmla="*/ 0 h 18288"/>
+              <a:gd name="csX3" fmla="*/ 2015338 w 3474720"/>
+              <a:gd name="csY3" fmla="*/ 0 h 18288"/>
+              <a:gd name="csX4" fmla="*/ 2779776 w 3474720"/>
+              <a:gd name="csY4" fmla="*/ 0 h 18288"/>
+              <a:gd name="csX5" fmla="*/ 3474720 w 3474720"/>
+              <a:gd name="csY5" fmla="*/ 0 h 18288"/>
+              <a:gd name="csX6" fmla="*/ 3474720 w 3474720"/>
+              <a:gd name="csY6" fmla="*/ 18288 h 18288"/>
+              <a:gd name="csX7" fmla="*/ 2779776 w 3474720"/>
+              <a:gd name="csY7" fmla="*/ 18288 h 18288"/>
+              <a:gd name="csX8" fmla="*/ 2189074 w 3474720"/>
+              <a:gd name="csY8" fmla="*/ 18288 h 18288"/>
+              <a:gd name="csX9" fmla="*/ 1528877 w 3474720"/>
+              <a:gd name="csY9" fmla="*/ 18288 h 18288"/>
+              <a:gd name="csX10" fmla="*/ 868680 w 3474720"/>
+              <a:gd name="csY10" fmla="*/ 18288 h 18288"/>
+              <a:gd name="csX11" fmla="*/ 0 w 3474720"/>
+              <a:gd name="csY11" fmla="*/ 18288 h 18288"/>
+              <a:gd name="csX12" fmla="*/ 0 w 3474720"/>
+              <a:gd name="csY12" fmla="*/ 0 h 18288"/>
             </a:gdLst>
             <a:ahLst/>
             <a:cxnLst>
               <a:cxn ang="0">
-                <a:pos x="connsiteX0" y="connsiteY0"/>
+                <a:pos x="csX0" y="csY0"/>
               </a:cxn>
               <a:cxn ang="0">
-                <a:pos x="connsiteX1" y="connsiteY1"/>
+                <a:pos x="csX1" y="csY1"/>
               </a:cxn>
               <a:cxn ang="0">
-                <a:pos x="connsiteX2" y="connsiteY2"/>
+                <a:pos x="csX2" y="csY2"/>
               </a:cxn>
               <a:cxn ang="0">
-                <a:pos x="connsiteX3" y="connsiteY3"/>
+                <a:pos x="csX3" y="csY3"/>
               </a:cxn>
               <a:cxn ang="0">
-                <a:pos x="connsiteX4" y="connsiteY4"/>
+                <a:pos x="csX4" y="csY4"/>
               </a:cxn>
               <a:cxn ang="0">
-                <a:pos x="connsiteX5" y="connsiteY5"/>
+                <a:pos x="csX5" y="csY5"/>
               </a:cxn>
               <a:cxn ang="0">
-                <a:pos x="connsiteX6" y="connsiteY6"/>
+                <a:pos x="csX6" y="csY6"/>
               </a:cxn>
               <a:cxn ang="0">
-                <a:pos x="connsiteX7" y="connsiteY7"/>
+                <a:pos x="csX7" y="csY7"/>
               </a:cxn>
               <a:cxn ang="0">
-                <a:pos x="connsiteX8" y="connsiteY8"/>
+                <a:pos x="csX8" y="csY8"/>
               </a:cxn>
               <a:cxn ang="0">
-                <a:pos x="connsiteX9" y="connsiteY9"/>
+                <a:pos x="csX9" y="csY9"/>
               </a:cxn>
               <a:cxn ang="0">
-                <a:pos x="connsiteX10" y="connsiteY10"/>
+                <a:pos x="csX10" y="csY10"/>
               </a:cxn>
               <a:cxn ang="0">
-                <a:pos x="connsiteX11" y="connsiteY11"/>
+                <a:pos x="csX11" y="csY11"/>
               </a:cxn>
               <a:cxn ang="0">
-                <a:pos x="connsiteX12" y="connsiteY12"/>
+                <a:pos x="csX12" y="csY12"/>
               </a:cxn>
             </a:cxnLst>
             <a:rect l="l" t="t" r="r" b="b"/>

</xml_diff>